<commit_message>
Add the five live, scrollable website designs and link them from both decks
- designs/: the five homepage concepts from the ACE design handoff, plus
  the booking wizard and Round 2 concepts; React bundled locally
- Short links per design (designs/bigsky.html etc.) open the right tab
- HTML deck: Open live buttons, clickable thumbnails, W shortcut
- PowerPoint: Open live links on every design slide and thumbnail

Co-Authored-By: Claude Opus 5.5 <noreply@anthropic.com>
Claude-Session: https://claude.ai/code/session_01JdqHZ2VXsSSMMnhf2KcPcP
</commit_message>
<xml_diff>
--- a/ACE-Design-Review.pptx
+++ b/ACE-Design-Review.pptx
@@ -128,14 +128,14 @@
   <p:extLst>
     <p:ext uri="{521415D9-36F7-43E2-AB2F-B90AF26B5E84}">
       <p14:sectionLst xmlns:p14="http://schemas.microsoft.com/office/powerpoint/2010/main">
-        <p14:section name="Opening" id="{d3f23f84-1aff-a300-afa6-f1f5b6601bd2}">
+        <p14:section name="Opening" id="{a03101f6-f368-851e-9653-8340c515b4aa}">
           <p14:sldIdLst>
             <p14:sldId id="256"/>
             <p14:sldId id="257"/>
             <p14:sldId id="258"/>
           </p14:sldIdLst>
         </p14:section>
-        <p14:section name="Designs" id="{9ff2171c-9acb-f79e-20af-abc40df62800}">
+        <p14:section name="Designs" id="{129dbf8f-3db1-2915-0400-9c344852809b}">
           <p14:sldIdLst>
             <p14:sldId id="259"/>
             <p14:sldId id="260"/>
@@ -147,7 +147,7 @@
             <p14:sldId id="266"/>
           </p14:sldIdLst>
         </p14:section>
-        <p14:section name="Accountability (EOS)" id="{f9c88814-a3f1-cbed-93f6-997833219ebe}">
+        <p14:section name="Accountability (EOS)" id="{6af45d7f-6c35-b07b-3fa5-55fd4b4a5f9e}">
           <p14:sldIdLst>
             <p14:sldId id="267"/>
             <p14:sldId id="268"/>
@@ -156,13 +156,13 @@
             <p14:sldId id="271"/>
           </p14:sldIdLst>
         </p14:section>
-        <p14:section name="Decision" id="{4af143c6-de48-ddad-e8d0-2d50cedd9597}">
+        <p14:section name="Decision" id="{4c05f172-8ba5-e402-ed3a-766acaaf9479}">
           <p14:sldIdLst>
             <p14:sldId id="272"/>
             <p14:sldId id="273"/>
           </p14:sldIdLst>
         </p14:section>
-        <p14:section name="Appendix" id="{9838dc1e-8b39-4e66-ccfe-97c12f231cd1}">
+        <p14:section name="Appendix" id="{f5aadcba-df85-09d9-753b-8320ec6c39b5}">
           <p14:sldIdLst>
             <p14:sldId id="274"/>
             <p14:sldId id="275"/>
@@ -9935,7 +9935,7 @@
         <p:spPr>
           <a:xfrm>
             <a:off x="2209648" y="5998797"/>
-            <a:ext cx="3291840" cy="457200"/>
+            <a:ext cx="2606040" cy="457200"/>
           </a:xfrm>
           <a:prstGeom prst="rect">
             <a:avLst/>
@@ -9973,8 +9973,8 @@
         </p:nvSpPr>
         <p:spPr>
           <a:xfrm>
-            <a:off x="5364328" y="6053661"/>
-            <a:ext cx="3291840" cy="365760"/>
+            <a:off x="4861408" y="6053661"/>
+            <a:ext cx="2560320" cy="365760"/>
           </a:xfrm>
           <a:prstGeom prst="rect">
             <a:avLst/>
@@ -10003,13 +10003,58 @@
       </p:sp>
       <p:sp>
         <p:nvSpPr>
-          <p:cNvPr id="10" name="Text 7"/>
+          <p:cNvPr id="10" name="Piney Woods live link"/>
           <p:cNvSpPr txBox="1"/>
           <p:nvPr/>
         </p:nvSpPr>
         <p:spPr>
           <a:xfrm>
-            <a:off x="8976208" y="6035373"/>
+            <a:off x="9159088" y="6035373"/>
+            <a:ext cx="1325880" cy="329184"/>
+          </a:xfrm>
+          <a:prstGeom prst="rect">
+            <a:avLst/>
+          </a:prstGeom>
+          <a:solidFill>
+            <a:schemeClr val="accent1"/>
+          </a:solidFill>
+          <a:ln/>
+        </p:spPr>
+        <p:txBody>
+          <a:bodyPr wrap="square" lIns="0" tIns="0" rIns="0" bIns="0" rtlCol="0" anchor="ctr"/>
+          <a:lstStyle/>
+          <a:p>
+            <a:pPr algn="ctr" indent="0" marL="0">
+              <a:buNone/>
+            </a:pPr>
+            <a:r>
+              <a:rPr lang="en-US" sz="1000" b="1" u="sng" spc="200" kern="0" dirty="0">
+                <a:solidFill>
+                  <a:schemeClr val="tx2"/>
+                </a:solidFill>
+                <a:hlinkClick r:id="rId2" invalidUrl="" action="" tgtFrame="" tooltip="Open the Piney Woods live site" history="1" highlightClick="0" endSnd="0">
+                  <a:extLst>
+                    <a:ext uri="{A12FA001-AC4F-418D-AE19-62706E023703}">
+                      <ahyp:hlinkClr xmlns:ahyp="http://schemas.microsoft.com/office/drawing/2018/hyperlinkcolor" val="tx"/>
+                    </a:ext>
+                  </a:extLst>
+                </a:hlinkClick>
+              </a:rPr>
+              <a:t>OPEN LIVE ↗</a:t>
+            </a:r>
+            <a:endParaRPr lang="en-US" sz="1000" dirty="0"/>
+          </a:p>
+        </p:txBody>
+      </p:sp>
+      <p:sp>
+        <p:nvSpPr>
+          <p:cNvPr id="11" name="Text 8"/>
+          <p:cNvSpPr txBox="1"/>
+          <p:nvPr/>
+        </p:nvSpPr>
+        <p:spPr>
+          <a:xfrm>
+            <a:off x="7513168" y="6035373"/>
             <a:ext cx="1508760" cy="329184"/>
           </a:xfrm>
           <a:prstGeom prst="rect">
@@ -10242,7 +10287,7 @@
         <p:spPr>
           <a:xfrm>
             <a:off x="2209648" y="5998797"/>
-            <a:ext cx="3291840" cy="457200"/>
+            <a:ext cx="2606040" cy="457200"/>
           </a:xfrm>
           <a:prstGeom prst="rect">
             <a:avLst/>
@@ -10280,8 +10325,8 @@
         </p:nvSpPr>
         <p:spPr>
           <a:xfrm>
-            <a:off x="5364328" y="6053661"/>
-            <a:ext cx="3291840" cy="365760"/>
+            <a:off x="4861408" y="6053661"/>
+            <a:ext cx="2560320" cy="365760"/>
           </a:xfrm>
           <a:prstGeom prst="rect">
             <a:avLst/>
@@ -10310,13 +10355,58 @@
       </p:sp>
       <p:sp>
         <p:nvSpPr>
-          <p:cNvPr id="10" name="Text 7"/>
+          <p:cNvPr id="10" name="Open Water live link"/>
           <p:cNvSpPr txBox="1"/>
           <p:nvPr/>
         </p:nvSpPr>
         <p:spPr>
           <a:xfrm>
-            <a:off x="8976208" y="6035373"/>
+            <a:off x="9159088" y="6035373"/>
+            <a:ext cx="1325880" cy="329184"/>
+          </a:xfrm>
+          <a:prstGeom prst="rect">
+            <a:avLst/>
+          </a:prstGeom>
+          <a:solidFill>
+            <a:schemeClr val="accent1"/>
+          </a:solidFill>
+          <a:ln/>
+        </p:spPr>
+        <p:txBody>
+          <a:bodyPr wrap="square" lIns="0" tIns="0" rIns="0" bIns="0" rtlCol="0" anchor="ctr"/>
+          <a:lstStyle/>
+          <a:p>
+            <a:pPr algn="ctr" indent="0" marL="0">
+              <a:buNone/>
+            </a:pPr>
+            <a:r>
+              <a:rPr lang="en-US" sz="1000" b="1" u="sng" spc="200" kern="0" dirty="0">
+                <a:solidFill>
+                  <a:schemeClr val="tx2"/>
+                </a:solidFill>
+                <a:hlinkClick r:id="rId2" invalidUrl="" action="" tgtFrame="" tooltip="Open the Open Water live site" history="1" highlightClick="0" endSnd="0">
+                  <a:extLst>
+                    <a:ext uri="{A12FA001-AC4F-418D-AE19-62706E023703}">
+                      <ahyp:hlinkClr xmlns:ahyp="http://schemas.microsoft.com/office/drawing/2018/hyperlinkcolor" val="tx"/>
+                    </a:ext>
+                  </a:extLst>
+                </a:hlinkClick>
+              </a:rPr>
+              <a:t>OPEN LIVE ↗</a:t>
+            </a:r>
+            <a:endParaRPr lang="en-US" sz="1000" dirty="0"/>
+          </a:p>
+        </p:txBody>
+      </p:sp>
+      <p:sp>
+        <p:nvSpPr>
+          <p:cNvPr id="11" name="Text 8"/>
+          <p:cNvSpPr txBox="1"/>
+          <p:nvPr/>
+        </p:nvSpPr>
+        <p:spPr>
+          <a:xfrm>
+            <a:off x="7513168" y="6035373"/>
             <a:ext cx="1508760" cy="329184"/>
           </a:xfrm>
           <a:prstGeom prst="rect">
@@ -10549,7 +10639,7 @@
         <p:spPr>
           <a:xfrm>
             <a:off x="2209648" y="5998797"/>
-            <a:ext cx="3291840" cy="457200"/>
+            <a:ext cx="2606040" cy="457200"/>
           </a:xfrm>
           <a:prstGeom prst="rect">
             <a:avLst/>
@@ -10587,8 +10677,8 @@
         </p:nvSpPr>
         <p:spPr>
           <a:xfrm>
-            <a:off x="5364328" y="6053661"/>
-            <a:ext cx="3291840" cy="365760"/>
+            <a:off x="4861408" y="6053661"/>
+            <a:ext cx="2560320" cy="365760"/>
           </a:xfrm>
           <a:prstGeom prst="rect">
             <a:avLst/>
@@ -10617,13 +10707,58 @@
       </p:sp>
       <p:sp>
         <p:nvSpPr>
-          <p:cNvPr id="10" name="Text 7"/>
+          <p:cNvPr id="10" name="Hill Country live link"/>
           <p:cNvSpPr txBox="1"/>
           <p:nvPr/>
         </p:nvSpPr>
         <p:spPr>
           <a:xfrm>
-            <a:off x="8976208" y="6035373"/>
+            <a:off x="9159088" y="6035373"/>
+            <a:ext cx="1325880" cy="329184"/>
+          </a:xfrm>
+          <a:prstGeom prst="rect">
+            <a:avLst/>
+          </a:prstGeom>
+          <a:solidFill>
+            <a:schemeClr val="accent1"/>
+          </a:solidFill>
+          <a:ln/>
+        </p:spPr>
+        <p:txBody>
+          <a:bodyPr wrap="square" lIns="0" tIns="0" rIns="0" bIns="0" rtlCol="0" anchor="ctr"/>
+          <a:lstStyle/>
+          <a:p>
+            <a:pPr algn="ctr" indent="0" marL="0">
+              <a:buNone/>
+            </a:pPr>
+            <a:r>
+              <a:rPr lang="en-US" sz="1000" b="1" u="sng" spc="200" kern="0" dirty="0">
+                <a:solidFill>
+                  <a:schemeClr val="tx2"/>
+                </a:solidFill>
+                <a:hlinkClick r:id="rId2" invalidUrl="" action="" tgtFrame="" tooltip="Open the Hill Country live site" history="1" highlightClick="0" endSnd="0">
+                  <a:extLst>
+                    <a:ext uri="{A12FA001-AC4F-418D-AE19-62706E023703}">
+                      <ahyp:hlinkClr xmlns:ahyp="http://schemas.microsoft.com/office/drawing/2018/hyperlinkcolor" val="tx"/>
+                    </a:ext>
+                  </a:extLst>
+                </a:hlinkClick>
+              </a:rPr>
+              <a:t>OPEN LIVE ↗</a:t>
+            </a:r>
+            <a:endParaRPr lang="en-US" sz="1000" dirty="0"/>
+          </a:p>
+        </p:txBody>
+      </p:sp>
+      <p:sp>
+        <p:nvSpPr>
+          <p:cNvPr id="11" name="Text 8"/>
+          <p:cNvSpPr txBox="1"/>
+          <p:nvPr/>
+        </p:nvSpPr>
+        <p:spPr>
+          <a:xfrm>
+            <a:off x="7513168" y="6035373"/>
             <a:ext cx="1508760" cy="329184"/>
           </a:xfrm>
           <a:prstGeom prst="rect">
@@ -11015,7 +11150,9 @@
       </p:sp>
       <p:pic>
         <p:nvPicPr>
-          <p:cNvPr id="5" name="Big Sky thumb" descr="Big Sky">    </p:cNvPr>
+          <p:cNvPr id="5" name="Big Sky thumb" descr="Big Sky">
+            <a:hlinkClick r:id="rId2" tooltip="Open the Big Sky live site"/>
+          </p:cNvPr>
           <p:cNvPicPr>
             <a:picLocks noChangeAspect="1"/>
           </p:cNvPicPr>
@@ -11150,144 +11287,9 @@
       </p:sp>
       <p:pic>
         <p:nvPicPr>
-          <p:cNvPr id="9" name="Piney Woods thumb" descr="Piney Woods">    </p:cNvPr>
-          <p:cNvPicPr>
-            <a:picLocks noChangeAspect="1"/>
-          </p:cNvPicPr>
-          <p:nvPr/>
-        </p:nvPicPr>
-        <p:blipFill>
-          <a:blip r:embed="rId2">
-            <a:alphaModFix amt="45000"/>
-          </a:blip>
-          <a:stretch>
-            <a:fillRect/>
-          </a:stretch>
-        </p:blipFill>
-        <p:spPr>
-          <a:xfrm>
-            <a:off x="3025384" y="2743200"/>
-            <a:ext cx="1864096" cy="1091343"/>
-          </a:xfrm>
-          <a:prstGeom prst="rect">
-            <a:avLst/>
-          </a:prstGeom>
-        </p:spPr>
-      </p:pic>
-      <p:sp>
-        <p:nvSpPr>
-          <p:cNvPr id="10" name="Text 6"/>
-          <p:cNvSpPr txBox="1"/>
-          <p:nvPr/>
-        </p:nvSpPr>
-        <p:spPr>
-          <a:xfrm>
-            <a:off x="3025384" y="4063143"/>
-            <a:ext cx="1864096" cy="228600"/>
-          </a:xfrm>
-          <a:prstGeom prst="rect">
-            <a:avLst/>
-          </a:prstGeom>
-          <a:noFill/>
-          <a:ln/>
-        </p:spPr>
-        <p:txBody>
-          <a:bodyPr wrap="square" lIns="0" tIns="0" rIns="0" bIns="0" rtlCol="0" anchor="t"/>
-          <a:lstStyle/>
-          <a:p>
-            <a:pPr indent="0" marL="0">
-              <a:buNone/>
-            </a:pPr>
-            <a:r>
-              <a:rPr lang="en-US" sz="1000" b="1" spc="200" kern="0" dirty="0">
-                <a:solidFill>
-                  <a:schemeClr val="accent1"/>
-                </a:solidFill>
-              </a:rPr>
-              <a:t>02</a:t>
-            </a:r>
-            <a:endParaRPr lang="en-US" sz="1000" dirty="0"/>
-          </a:p>
-        </p:txBody>
-      </p:sp>
-      <p:sp>
-        <p:nvSpPr>
-          <p:cNvPr id="11" name="Text 7"/>
-          <p:cNvSpPr txBox="1"/>
-          <p:nvPr/>
-        </p:nvSpPr>
-        <p:spPr>
-          <a:xfrm>
-            <a:off x="3025384" y="4310031"/>
-            <a:ext cx="1864096" cy="365760"/>
-          </a:xfrm>
-          <a:prstGeom prst="rect">
-            <a:avLst/>
-          </a:prstGeom>
-          <a:noFill/>
-          <a:ln/>
-        </p:spPr>
-        <p:txBody>
-          <a:bodyPr wrap="square" lIns="0" tIns="0" rIns="0" bIns="0" rtlCol="0" anchor="t"/>
-          <a:lstStyle/>
-          <a:p>
-            <a:pPr indent="0" marL="0">
-              <a:buNone/>
-            </a:pPr>
-            <a:r>
-              <a:rPr lang="en-US" sz="1800" b="1" dirty="0">
-                <a:solidFill>
-                  <a:srgbClr val="8C826F"/>
-                </a:solidFill>
-                <a:latin typeface="Cambria" pitchFamily="34" charset="0"/>
-                <a:ea typeface="Cambria" pitchFamily="34" charset="-122"/>
-                <a:cs typeface="Cambria" pitchFamily="34" charset="-120"/>
-              </a:rPr>
-              <a:t>Piney Woods</a:t>
-            </a:r>
-            <a:endParaRPr lang="en-US" sz="1800" dirty="0"/>
-          </a:p>
-        </p:txBody>
-      </p:sp>
-      <p:sp>
-        <p:nvSpPr>
-          <p:cNvPr id="12" name="Text 8"/>
-          <p:cNvSpPr txBox="1"/>
-          <p:nvPr/>
-        </p:nvSpPr>
-        <p:spPr>
-          <a:xfrm>
-            <a:off x="3025384" y="4675791"/>
-            <a:ext cx="1864096" cy="365760"/>
-          </a:xfrm>
-          <a:prstGeom prst="rect">
-            <a:avLst/>
-          </a:prstGeom>
-          <a:noFill/>
-          <a:ln/>
-        </p:spPr>
-        <p:txBody>
-          <a:bodyPr wrap="square" lIns="0" tIns="0" rIns="0" bIns="0" rtlCol="0" anchor="t"/>
-          <a:lstStyle/>
-          <a:p>
-            <a:pPr indent="0" marL="0">
-              <a:buNone/>
-            </a:pPr>
-            <a:r>
-              <a:rPr lang="en-US" sz="1200" dirty="0">
-                <a:solidFill>
-                  <a:srgbClr val="6E6656"/>
-                </a:solidFill>
-              </a:rPr>
-              <a:t>Rooted, calm, organic.</a:t>
-            </a:r>
-            <a:endParaRPr lang="en-US" sz="1200" dirty="0"/>
-          </a:p>
-        </p:txBody>
-      </p:sp>
-      <p:pic>
-        <p:nvPicPr>
-          <p:cNvPr id="13" name="Open Water thumb" descr="Open Water">    </p:cNvPr>
+          <p:cNvPr id="9" name="Piney Woods thumb" descr="Piney Woods">
+            <a:hlinkClick r:id="rId4" tooltip="Open the Piney Woods live site"/>
+          </p:cNvPr>
           <p:cNvPicPr>
             <a:picLocks noChangeAspect="1"/>
           </p:cNvPicPr>
@@ -11303,6 +11305,145 @@
         </p:blipFill>
         <p:spPr>
           <a:xfrm>
+            <a:off x="3025384" y="2743200"/>
+            <a:ext cx="1864096" cy="1091343"/>
+          </a:xfrm>
+          <a:prstGeom prst="rect">
+            <a:avLst/>
+          </a:prstGeom>
+        </p:spPr>
+      </p:pic>
+      <p:sp>
+        <p:nvSpPr>
+          <p:cNvPr id="10" name="Text 6"/>
+          <p:cNvSpPr txBox="1"/>
+          <p:nvPr/>
+        </p:nvSpPr>
+        <p:spPr>
+          <a:xfrm>
+            <a:off x="3025384" y="4063143"/>
+            <a:ext cx="1864096" cy="228600"/>
+          </a:xfrm>
+          <a:prstGeom prst="rect">
+            <a:avLst/>
+          </a:prstGeom>
+          <a:noFill/>
+          <a:ln/>
+        </p:spPr>
+        <p:txBody>
+          <a:bodyPr wrap="square" lIns="0" tIns="0" rIns="0" bIns="0" rtlCol="0" anchor="t"/>
+          <a:lstStyle/>
+          <a:p>
+            <a:pPr indent="0" marL="0">
+              <a:buNone/>
+            </a:pPr>
+            <a:r>
+              <a:rPr lang="en-US" sz="1000" b="1" spc="200" kern="0" dirty="0">
+                <a:solidFill>
+                  <a:schemeClr val="accent1"/>
+                </a:solidFill>
+              </a:rPr>
+              <a:t>02</a:t>
+            </a:r>
+            <a:endParaRPr lang="en-US" sz="1000" dirty="0"/>
+          </a:p>
+        </p:txBody>
+      </p:sp>
+      <p:sp>
+        <p:nvSpPr>
+          <p:cNvPr id="11" name="Text 7"/>
+          <p:cNvSpPr txBox="1"/>
+          <p:nvPr/>
+        </p:nvSpPr>
+        <p:spPr>
+          <a:xfrm>
+            <a:off x="3025384" y="4310031"/>
+            <a:ext cx="1864096" cy="365760"/>
+          </a:xfrm>
+          <a:prstGeom prst="rect">
+            <a:avLst/>
+          </a:prstGeom>
+          <a:noFill/>
+          <a:ln/>
+        </p:spPr>
+        <p:txBody>
+          <a:bodyPr wrap="square" lIns="0" tIns="0" rIns="0" bIns="0" rtlCol="0" anchor="t"/>
+          <a:lstStyle/>
+          <a:p>
+            <a:pPr indent="0" marL="0">
+              <a:buNone/>
+            </a:pPr>
+            <a:r>
+              <a:rPr lang="en-US" sz="1800" b="1" dirty="0">
+                <a:solidFill>
+                  <a:srgbClr val="8C826F"/>
+                </a:solidFill>
+                <a:latin typeface="Cambria" pitchFamily="34" charset="0"/>
+                <a:ea typeface="Cambria" pitchFamily="34" charset="-122"/>
+                <a:cs typeface="Cambria" pitchFamily="34" charset="-120"/>
+              </a:rPr>
+              <a:t>Piney Woods</a:t>
+            </a:r>
+            <a:endParaRPr lang="en-US" sz="1800" dirty="0"/>
+          </a:p>
+        </p:txBody>
+      </p:sp>
+      <p:sp>
+        <p:nvSpPr>
+          <p:cNvPr id="12" name="Text 8"/>
+          <p:cNvSpPr txBox="1"/>
+          <p:nvPr/>
+        </p:nvSpPr>
+        <p:spPr>
+          <a:xfrm>
+            <a:off x="3025384" y="4675791"/>
+            <a:ext cx="1864096" cy="365760"/>
+          </a:xfrm>
+          <a:prstGeom prst="rect">
+            <a:avLst/>
+          </a:prstGeom>
+          <a:noFill/>
+          <a:ln/>
+        </p:spPr>
+        <p:txBody>
+          <a:bodyPr wrap="square" lIns="0" tIns="0" rIns="0" bIns="0" rtlCol="0" anchor="t"/>
+          <a:lstStyle/>
+          <a:p>
+            <a:pPr indent="0" marL="0">
+              <a:buNone/>
+            </a:pPr>
+            <a:r>
+              <a:rPr lang="en-US" sz="1200" dirty="0">
+                <a:solidFill>
+                  <a:srgbClr val="6E6656"/>
+                </a:solidFill>
+              </a:rPr>
+              <a:t>Rooted, calm, organic.</a:t>
+            </a:r>
+            <a:endParaRPr lang="en-US" sz="1200" dirty="0"/>
+          </a:p>
+        </p:txBody>
+      </p:sp>
+      <p:pic>
+        <p:nvPicPr>
+          <p:cNvPr id="13" name="Open Water thumb" descr="Open Water">
+            <a:hlinkClick r:id="rId6" tooltip="Open the Open Water live site"/>
+          </p:cNvPr>
+          <p:cNvPicPr>
+            <a:picLocks noChangeAspect="1"/>
+          </p:cNvPicPr>
+          <p:nvPr/>
+        </p:nvPicPr>
+        <p:blipFill>
+          <a:blip r:embed="rId5">
+            <a:alphaModFix amt="45000"/>
+          </a:blip>
+          <a:stretch>
+            <a:fillRect/>
+          </a:stretch>
+        </p:blipFill>
+        <p:spPr>
+          <a:xfrm>
             <a:off x="5163800" y="2743200"/>
             <a:ext cx="1864096" cy="1091343"/>
           </a:xfrm>
@@ -11449,14 +11590,16 @@
       </p:sp>
       <p:pic>
         <p:nvPicPr>
-          <p:cNvPr id="18" name="Heartland Steel thumb" descr="Heartland Steel">    </p:cNvPr>
+          <p:cNvPr id="18" name="Heartland Steel thumb" descr="Heartland Steel">
+            <a:hlinkClick r:id="rId8" tooltip="Open the Heartland Steel live site"/>
+          </p:cNvPr>
           <p:cNvPicPr>
             <a:picLocks noChangeAspect="1"/>
           </p:cNvPicPr>
           <p:nvPr/>
         </p:nvPicPr>
         <p:blipFill>
-          <a:blip r:embed="rId4"/>
+          <a:blip r:embed="rId7"/>
           <a:stretch>
             <a:fillRect/>
           </a:stretch>
@@ -11584,14 +11727,16 @@
       </p:sp>
       <p:pic>
         <p:nvPicPr>
-          <p:cNvPr id="22" name="Hill Country thumb" descr="Hill Country">    </p:cNvPr>
+          <p:cNvPr id="22" name="Hill Country thumb" descr="Hill Country">
+            <a:hlinkClick r:id="rId10" tooltip="Open the Hill Country live site"/>
+          </p:cNvPr>
           <p:cNvPicPr>
             <a:picLocks noChangeAspect="1"/>
           </p:cNvPicPr>
           <p:nvPr/>
         </p:nvPicPr>
         <p:blipFill>
-          <a:blip r:embed="rId5">
+          <a:blip r:embed="rId9">
             <a:alphaModFix amt="45000"/>
           </a:blip>
           <a:stretch>
@@ -11965,7 +12110,7 @@
         <p:spPr>
           <a:xfrm>
             <a:off x="2209648" y="5998797"/>
-            <a:ext cx="3291840" cy="457200"/>
+            <a:ext cx="2606040" cy="457200"/>
           </a:xfrm>
           <a:prstGeom prst="rect">
             <a:avLst/>
@@ -12003,8 +12148,8 @@
         </p:nvSpPr>
         <p:spPr>
           <a:xfrm>
-            <a:off x="5364328" y="6053661"/>
-            <a:ext cx="3291840" cy="365760"/>
+            <a:off x="4861408" y="6053661"/>
+            <a:ext cx="2560320" cy="365760"/>
           </a:xfrm>
           <a:prstGeom prst="rect">
             <a:avLst/>
@@ -12033,13 +12178,58 @@
       </p:sp>
       <p:sp>
         <p:nvSpPr>
-          <p:cNvPr id="10" name="Text 7"/>
+          <p:cNvPr id="10" name="Big Sky live link"/>
           <p:cNvSpPr txBox="1"/>
           <p:nvPr/>
         </p:nvSpPr>
         <p:spPr>
           <a:xfrm>
-            <a:off x="8976208" y="6035373"/>
+            <a:off x="9159088" y="6035373"/>
+            <a:ext cx="1325880" cy="329184"/>
+          </a:xfrm>
+          <a:prstGeom prst="rect">
+            <a:avLst/>
+          </a:prstGeom>
+          <a:solidFill>
+            <a:schemeClr val="accent1"/>
+          </a:solidFill>
+          <a:ln/>
+        </p:spPr>
+        <p:txBody>
+          <a:bodyPr wrap="square" lIns="0" tIns="0" rIns="0" bIns="0" rtlCol="0" anchor="ctr"/>
+          <a:lstStyle/>
+          <a:p>
+            <a:pPr algn="ctr" indent="0" marL="0">
+              <a:buNone/>
+            </a:pPr>
+            <a:r>
+              <a:rPr lang="en-US" sz="1000" b="1" u="sng" spc="200" kern="0" dirty="0">
+                <a:solidFill>
+                  <a:schemeClr val="tx2"/>
+                </a:solidFill>
+                <a:hlinkClick r:id="rId2" invalidUrl="" action="" tgtFrame="" tooltip="Open the Big Sky live site" history="1" highlightClick="0" endSnd="0">
+                  <a:extLst>
+                    <a:ext uri="{A12FA001-AC4F-418D-AE19-62706E023703}">
+                      <ahyp:hlinkClr xmlns:ahyp="http://schemas.microsoft.com/office/drawing/2018/hyperlinkcolor" val="tx"/>
+                    </a:ext>
+                  </a:extLst>
+                </a:hlinkClick>
+              </a:rPr>
+              <a:t>OPEN LIVE ↗</a:t>
+            </a:r>
+            <a:endParaRPr lang="en-US" sz="1000" dirty="0"/>
+          </a:p>
+        </p:txBody>
+      </p:sp>
+      <p:sp>
+        <p:nvSpPr>
+          <p:cNvPr id="11" name="Text 8"/>
+          <p:cNvSpPr txBox="1"/>
+          <p:nvPr/>
+        </p:nvSpPr>
+        <p:spPr>
+          <a:xfrm>
+            <a:off x="7513168" y="6035373"/>
             <a:ext cx="1508760" cy="329184"/>
           </a:xfrm>
           <a:prstGeom prst="rect">
@@ -12229,7 +12419,52 @@
       </p:pic>
       <p:sp>
         <p:nvSpPr>
-          <p:cNvPr id="7" name="Text 4"/>
+          <p:cNvPr id="7" name="Big Sky live link"/>
+          <p:cNvSpPr txBox="1"/>
+          <p:nvPr/>
+        </p:nvSpPr>
+        <p:spPr>
+          <a:xfrm>
+            <a:off x="886968" y="5474596"/>
+            <a:ext cx="2103120" cy="347472"/>
+          </a:xfrm>
+          <a:prstGeom prst="rect">
+            <a:avLst/>
+          </a:prstGeom>
+          <a:solidFill>
+            <a:schemeClr val="accent1"/>
+          </a:solidFill>
+          <a:ln/>
+        </p:spPr>
+        <p:txBody>
+          <a:bodyPr wrap="square" lIns="0" tIns="0" rIns="0" bIns="0" rtlCol="0" anchor="ctr"/>
+          <a:lstStyle/>
+          <a:p>
+            <a:pPr algn="ctr" indent="0" marL="0">
+              <a:buNone/>
+            </a:pPr>
+            <a:r>
+              <a:rPr lang="en-US" sz="1000" b="1" u="sng" spc="200" kern="0" dirty="0">
+                <a:solidFill>
+                  <a:schemeClr val="tx2"/>
+                </a:solidFill>
+                <a:hlinkClick r:id="rId2" invalidUrl="" action="" tgtFrame="" tooltip="Open the Big Sky live site" history="1" highlightClick="0" endSnd="0">
+                  <a:extLst>
+                    <a:ext uri="{A12FA001-AC4F-418D-AE19-62706E023703}">
+                      <ahyp:hlinkClr xmlns:ahyp="http://schemas.microsoft.com/office/drawing/2018/hyperlinkcolor" val="tx"/>
+                    </a:ext>
+                  </a:extLst>
+                </a:hlinkClick>
+              </a:rPr>
+              <a:t>OPEN THE LIVE SITE ↗</a:t>
+            </a:r>
+            <a:endParaRPr lang="en-US" sz="1000" dirty="0"/>
+          </a:p>
+        </p:txBody>
+      </p:sp>
+      <p:sp>
+        <p:nvSpPr>
+          <p:cNvPr id="8" name="Text 5"/>
           <p:cNvSpPr txBox="1"/>
           <p:nvPr/>
         </p:nvSpPr>
@@ -12265,7 +12500,7 @@
       </p:sp>
       <p:sp>
         <p:nvSpPr>
-          <p:cNvPr id="8" name="Text 5"/>
+          <p:cNvPr id="9" name="Text 6"/>
           <p:cNvSpPr txBox="1"/>
           <p:nvPr/>
         </p:nvSpPr>
@@ -12304,7 +12539,7 @@
       </p:sp>
       <p:sp>
         <p:nvSpPr>
-          <p:cNvPr id="9" name="Text 6"/>
+          <p:cNvPr id="10" name="Text 7"/>
           <p:cNvSpPr txBox="1"/>
           <p:nvPr/>
         </p:nvSpPr>
@@ -12343,7 +12578,7 @@
       </p:sp>
       <p:sp>
         <p:nvSpPr>
-          <p:cNvPr id="10" name="Text 7"/>
+          <p:cNvPr id="11" name="Text 8"/>
           <p:cNvSpPr txBox="1"/>
           <p:nvPr/>
         </p:nvSpPr>
@@ -12493,7 +12728,7 @@
       </p:sp>
       <p:sp>
         <p:nvSpPr>
-          <p:cNvPr id="11" name="swatch 1"/>
+          <p:cNvPr id="12" name="swatch 1"/>
           <p:cNvSpPr/>
           <p:nvPr/>
         </p:nvSpPr>
@@ -12518,7 +12753,7 @@
       </p:sp>
       <p:sp>
         <p:nvSpPr>
-          <p:cNvPr id="12" name="swatch 2"/>
+          <p:cNvPr id="13" name="swatch 2"/>
           <p:cNvSpPr/>
           <p:nvPr/>
         </p:nvSpPr>
@@ -12543,7 +12778,7 @@
       </p:sp>
       <p:sp>
         <p:nvSpPr>
-          <p:cNvPr id="13" name="swatch 3"/>
+          <p:cNvPr id="14" name="swatch 3"/>
           <p:cNvSpPr/>
           <p:nvPr/>
         </p:nvSpPr>
@@ -12568,7 +12803,7 @@
       </p:sp>
       <p:sp>
         <p:nvSpPr>
-          <p:cNvPr id="14" name="Text 11"/>
+          <p:cNvPr id="15" name="Text 12"/>
           <p:cNvSpPr txBox="1"/>
           <p:nvPr/>
         </p:nvSpPr>
@@ -12848,7 +13083,7 @@
         <p:spPr>
           <a:xfrm>
             <a:off x="2209648" y="5998797"/>
-            <a:ext cx="3291840" cy="457200"/>
+            <a:ext cx="2606040" cy="457200"/>
           </a:xfrm>
           <a:prstGeom prst="rect">
             <a:avLst/>
@@ -12886,8 +13121,8 @@
         </p:nvSpPr>
         <p:spPr>
           <a:xfrm>
-            <a:off x="5364328" y="6053661"/>
-            <a:ext cx="3291840" cy="365760"/>
+            <a:off x="4861408" y="6053661"/>
+            <a:ext cx="2560320" cy="365760"/>
           </a:xfrm>
           <a:prstGeom prst="rect">
             <a:avLst/>
@@ -12916,13 +13151,58 @@
       </p:sp>
       <p:sp>
         <p:nvSpPr>
-          <p:cNvPr id="10" name="Text 7"/>
+          <p:cNvPr id="10" name="Heartland Steel live link"/>
           <p:cNvSpPr txBox="1"/>
           <p:nvPr/>
         </p:nvSpPr>
         <p:spPr>
           <a:xfrm>
-            <a:off x="8976208" y="6035373"/>
+            <a:off x="9159088" y="6035373"/>
+            <a:ext cx="1325880" cy="329184"/>
+          </a:xfrm>
+          <a:prstGeom prst="rect">
+            <a:avLst/>
+          </a:prstGeom>
+          <a:solidFill>
+            <a:schemeClr val="accent1"/>
+          </a:solidFill>
+          <a:ln/>
+        </p:spPr>
+        <p:txBody>
+          <a:bodyPr wrap="square" lIns="0" tIns="0" rIns="0" bIns="0" rtlCol="0" anchor="ctr"/>
+          <a:lstStyle/>
+          <a:p>
+            <a:pPr algn="ctr" indent="0" marL="0">
+              <a:buNone/>
+            </a:pPr>
+            <a:r>
+              <a:rPr lang="en-US" sz="1000" b="1" u="sng" spc="200" kern="0" dirty="0">
+                <a:solidFill>
+                  <a:schemeClr val="tx2"/>
+                </a:solidFill>
+                <a:hlinkClick r:id="rId2" invalidUrl="" action="" tgtFrame="" tooltip="Open the Heartland Steel live site" history="1" highlightClick="0" endSnd="0">
+                  <a:extLst>
+                    <a:ext uri="{A12FA001-AC4F-418D-AE19-62706E023703}">
+                      <ahyp:hlinkClr xmlns:ahyp="http://schemas.microsoft.com/office/drawing/2018/hyperlinkcolor" val="tx"/>
+                    </a:ext>
+                  </a:extLst>
+                </a:hlinkClick>
+              </a:rPr>
+              <a:t>OPEN LIVE ↗</a:t>
+            </a:r>
+            <a:endParaRPr lang="en-US" sz="1000" dirty="0"/>
+          </a:p>
+        </p:txBody>
+      </p:sp>
+      <p:sp>
+        <p:nvSpPr>
+          <p:cNvPr id="11" name="Text 8"/>
+          <p:cNvSpPr txBox="1"/>
+          <p:nvPr/>
+        </p:nvSpPr>
+        <p:spPr>
+          <a:xfrm>
+            <a:off x="7513168" y="6035373"/>
             <a:ext cx="1508760" cy="329184"/>
           </a:xfrm>
           <a:prstGeom prst="rect">
@@ -13112,7 +13392,52 @@
       </p:pic>
       <p:sp>
         <p:nvSpPr>
-          <p:cNvPr id="7" name="Text 4"/>
+          <p:cNvPr id="7" name="Heartland Steel live link"/>
+          <p:cNvSpPr txBox="1"/>
+          <p:nvPr/>
+        </p:nvSpPr>
+        <p:spPr>
+          <a:xfrm>
+            <a:off x="886968" y="5474596"/>
+            <a:ext cx="2103120" cy="347472"/>
+          </a:xfrm>
+          <a:prstGeom prst="rect">
+            <a:avLst/>
+          </a:prstGeom>
+          <a:solidFill>
+            <a:schemeClr val="accent1"/>
+          </a:solidFill>
+          <a:ln/>
+        </p:spPr>
+        <p:txBody>
+          <a:bodyPr wrap="square" lIns="0" tIns="0" rIns="0" bIns="0" rtlCol="0" anchor="ctr"/>
+          <a:lstStyle/>
+          <a:p>
+            <a:pPr algn="ctr" indent="0" marL="0">
+              <a:buNone/>
+            </a:pPr>
+            <a:r>
+              <a:rPr lang="en-US" sz="1000" b="1" u="sng" spc="200" kern="0" dirty="0">
+                <a:solidFill>
+                  <a:schemeClr val="tx2"/>
+                </a:solidFill>
+                <a:hlinkClick r:id="rId2" invalidUrl="" action="" tgtFrame="" tooltip="Open the Heartland Steel live site" history="1" highlightClick="0" endSnd="0">
+                  <a:extLst>
+                    <a:ext uri="{A12FA001-AC4F-418D-AE19-62706E023703}">
+                      <ahyp:hlinkClr xmlns:ahyp="http://schemas.microsoft.com/office/drawing/2018/hyperlinkcolor" val="tx"/>
+                    </a:ext>
+                  </a:extLst>
+                </a:hlinkClick>
+              </a:rPr>
+              <a:t>OPEN THE LIVE SITE ↗</a:t>
+            </a:r>
+            <a:endParaRPr lang="en-US" sz="1000" dirty="0"/>
+          </a:p>
+        </p:txBody>
+      </p:sp>
+      <p:sp>
+        <p:nvSpPr>
+          <p:cNvPr id="8" name="Text 5"/>
           <p:cNvSpPr txBox="1"/>
           <p:nvPr/>
         </p:nvSpPr>
@@ -13148,7 +13473,7 @@
       </p:sp>
       <p:sp>
         <p:nvSpPr>
-          <p:cNvPr id="8" name="Text 5"/>
+          <p:cNvPr id="9" name="Text 6"/>
           <p:cNvSpPr txBox="1"/>
           <p:nvPr/>
         </p:nvSpPr>
@@ -13187,7 +13512,7 @@
       </p:sp>
       <p:sp>
         <p:nvSpPr>
-          <p:cNvPr id="9" name="Text 6"/>
+          <p:cNvPr id="10" name="Text 7"/>
           <p:cNvSpPr txBox="1"/>
           <p:nvPr/>
         </p:nvSpPr>
@@ -13226,7 +13551,7 @@
       </p:sp>
       <p:sp>
         <p:nvSpPr>
-          <p:cNvPr id="10" name="Text 7"/>
+          <p:cNvPr id="11" name="Text 8"/>
           <p:cNvSpPr txBox="1"/>
           <p:nvPr/>
         </p:nvSpPr>
@@ -13376,7 +13701,7 @@
       </p:sp>
       <p:sp>
         <p:nvSpPr>
-          <p:cNvPr id="11" name="swatch 1"/>
+          <p:cNvPr id="12" name="swatch 1"/>
           <p:cNvSpPr/>
           <p:nvPr/>
         </p:nvSpPr>
@@ -13401,7 +13726,7 @@
       </p:sp>
       <p:sp>
         <p:nvSpPr>
-          <p:cNvPr id="12" name="swatch 2"/>
+          <p:cNvPr id="13" name="swatch 2"/>
           <p:cNvSpPr/>
           <p:nvPr/>
         </p:nvSpPr>
@@ -13426,7 +13751,7 @@
       </p:sp>
       <p:sp>
         <p:nvSpPr>
-          <p:cNvPr id="13" name="swatch 3"/>
+          <p:cNvPr id="14" name="swatch 3"/>
           <p:cNvSpPr/>
           <p:nvPr/>
         </p:nvSpPr>
@@ -13451,7 +13776,7 @@
       </p:sp>
       <p:sp>
         <p:nvSpPr>
-          <p:cNvPr id="14" name="Text 11"/>
+          <p:cNvPr id="15" name="Text 12"/>
           <p:cNvSpPr txBox="1"/>
           <p:nvPr/>
         </p:nvSpPr>

</xml_diff>

<commit_message>
Point Open live links at the hosted designs so they work anywhere
Relative links only worked when the deck sat next to designs/; a downloaded
.pptx or a deck opened from Files had nowhere to go. Both decks now link to
the raw.githack copy of this branch (LIVE_BASE, swappable for GitHub Pages).

Co-Authored-By: Claude Opus 5.5 <noreply@anthropic.com>
Claude-Session: https://claude.ai/code/session_01JdqHZ2VXsSSMMnhf2KcPcP
</commit_message>
<xml_diff>
--- a/ACE-Design-Review.pptx
+++ b/ACE-Design-Review.pptx
@@ -128,14 +128,14 @@
   <p:extLst>
     <p:ext uri="{521415D9-36F7-43E2-AB2F-B90AF26B5E84}">
       <p14:sectionLst xmlns:p14="http://schemas.microsoft.com/office/powerpoint/2010/main">
-        <p14:section name="Opening" id="{a03101f6-f368-851e-9653-8340c515b4aa}">
+        <p14:section name="Opening" id="{e7f8fbf6-d81c-99c3-4ae2-f0d761888e29}">
           <p14:sldIdLst>
             <p14:sldId id="256"/>
             <p14:sldId id="257"/>
             <p14:sldId id="258"/>
           </p14:sldIdLst>
         </p14:section>
-        <p14:section name="Designs" id="{129dbf8f-3db1-2915-0400-9c344852809b}">
+        <p14:section name="Designs" id="{ec3aef3c-6ada-b998-2e57-595afebb4b90}">
           <p14:sldIdLst>
             <p14:sldId id="259"/>
             <p14:sldId id="260"/>
@@ -147,7 +147,7 @@
             <p14:sldId id="266"/>
           </p14:sldIdLst>
         </p14:section>
-        <p14:section name="Accountability (EOS)" id="{6af45d7f-6c35-b07b-3fa5-55fd4b4a5f9e}">
+        <p14:section name="Accountability (EOS)" id="{038f01d0-ce5e-67d3-c927-5580048d5164}">
           <p14:sldIdLst>
             <p14:sldId id="267"/>
             <p14:sldId id="268"/>
@@ -156,13 +156,13 @@
             <p14:sldId id="271"/>
           </p14:sldIdLst>
         </p14:section>
-        <p14:section name="Decision" id="{4c05f172-8ba5-e402-ed3a-766acaaf9479}">
+        <p14:section name="Decision" id="{39ddf658-4098-4563-0310-7544f93f0967}">
           <p14:sldIdLst>
             <p14:sldId id="272"/>
             <p14:sldId id="273"/>
           </p14:sldIdLst>
         </p14:section>
-        <p14:section name="Appendix" id="{f5aadcba-df85-09d9-753b-8320ec6c39b5}">
+        <p14:section name="Appendix" id="{c35f39a8-fd09-4964-0be5-f1f42a320e4a}">
           <p14:sldIdLst>
             <p14:sldId id="274"/>
             <p14:sldId id="275"/>

</xml_diff>

<commit_message>
Point live links at the main branch
Co-Authored-By: Claude Opus 5.5 <noreply@anthropic.com>
Claude-Session: https://claude.ai/code/session_01JdqHZ2VXsSSMMnhf2KcPcP
</commit_message>
<xml_diff>
--- a/ACE-Design-Review.pptx
+++ b/ACE-Design-Review.pptx
@@ -128,14 +128,14 @@
   <p:extLst>
     <p:ext uri="{521415D9-36F7-43E2-AB2F-B90AF26B5E84}">
       <p14:sectionLst xmlns:p14="http://schemas.microsoft.com/office/powerpoint/2010/main">
-        <p14:section name="Opening" id="{e7f8fbf6-d81c-99c3-4ae2-f0d761888e29}">
+        <p14:section name="Opening" id="{4363a54c-d85c-ca5c-36ab-8aed509959f5}">
           <p14:sldIdLst>
             <p14:sldId id="256"/>
             <p14:sldId id="257"/>
             <p14:sldId id="258"/>
           </p14:sldIdLst>
         </p14:section>
-        <p14:section name="Designs" id="{ec3aef3c-6ada-b998-2e57-595afebb4b90}">
+        <p14:section name="Designs" id="{365f59c0-1f47-0087-03af-723ae55864cf}">
           <p14:sldIdLst>
             <p14:sldId id="259"/>
             <p14:sldId id="260"/>
@@ -147,7 +147,7 @@
             <p14:sldId id="266"/>
           </p14:sldIdLst>
         </p14:section>
-        <p14:section name="Accountability (EOS)" id="{038f01d0-ce5e-67d3-c927-5580048d5164}">
+        <p14:section name="Accountability (EOS)" id="{a4ce24c2-2d6e-95b4-6fbb-faf24a32208b}">
           <p14:sldIdLst>
             <p14:sldId id="267"/>
             <p14:sldId id="268"/>
@@ -156,13 +156,13 @@
             <p14:sldId id="271"/>
           </p14:sldIdLst>
         </p14:section>
-        <p14:section name="Decision" id="{39ddf658-4098-4563-0310-7544f93f0967}">
+        <p14:section name="Decision" id="{aefc5e0c-b84a-a911-905a-e72ec3ba8461}">
           <p14:sldIdLst>
             <p14:sldId id="272"/>
             <p14:sldId id="273"/>
           </p14:sldIdLst>
         </p14:section>
-        <p14:section name="Appendix" id="{c35f39a8-fd09-4964-0be5-f1f42a320e4a}">
+        <p14:section name="Appendix" id="{9d87d2b0-b884-39fc-60f8-828a2331d1a9}">
           <p14:sldIdLst>
             <p14:sldId id="274"/>
             <p14:sldId id="275"/>

</xml_diff>

<commit_message>
Point live links at GitHub Pages
Co-Authored-By: Claude Opus 5.5 <noreply@anthropic.com>
Claude-Session: https://claude.ai/code/session_01JdqHZ2VXsSSMMnhf2KcPcP
</commit_message>
<xml_diff>
--- a/ACE-Design-Review.pptx
+++ b/ACE-Design-Review.pptx
@@ -128,14 +128,14 @@
   <p:extLst>
     <p:ext uri="{521415D9-36F7-43E2-AB2F-B90AF26B5E84}">
       <p14:sectionLst xmlns:p14="http://schemas.microsoft.com/office/powerpoint/2010/main">
-        <p14:section name="Opening" id="{4363a54c-d85c-ca5c-36ab-8aed509959f5}">
+        <p14:section name="Opening" id="{3d0a85f9-3e3e-2e2c-8785-2cd22f22d00d}">
           <p14:sldIdLst>
             <p14:sldId id="256"/>
             <p14:sldId id="257"/>
             <p14:sldId id="258"/>
           </p14:sldIdLst>
         </p14:section>
-        <p14:section name="Designs" id="{365f59c0-1f47-0087-03af-723ae55864cf}">
+        <p14:section name="Designs" id="{9176bed9-3973-6312-ebde-e8f77ba564bd}">
           <p14:sldIdLst>
             <p14:sldId id="259"/>
             <p14:sldId id="260"/>
@@ -147,7 +147,7 @@
             <p14:sldId id="266"/>
           </p14:sldIdLst>
         </p14:section>
-        <p14:section name="Accountability (EOS)" id="{a4ce24c2-2d6e-95b4-6fbb-faf24a32208b}">
+        <p14:section name="Accountability (EOS)" id="{fc5f1ad5-c56e-6f22-b7d7-3506058cc4f9}">
           <p14:sldIdLst>
             <p14:sldId id="267"/>
             <p14:sldId id="268"/>
@@ -156,13 +156,13 @@
             <p14:sldId id="271"/>
           </p14:sldIdLst>
         </p14:section>
-        <p14:section name="Decision" id="{aefc5e0c-b84a-a911-905a-e72ec3ba8461}">
+        <p14:section name="Decision" id="{fc578f1d-c760-c5ce-183c-88e84479a687}">
           <p14:sldIdLst>
             <p14:sldId id="272"/>
             <p14:sldId id="273"/>
           </p14:sldIdLst>
         </p14:section>
-        <p14:section name="Appendix" id="{9d87d2b0-b884-39fc-60f8-828a2331d1a9}">
+        <p14:section name="Appendix" id="{b5bcb4f9-afb9-8777-e517-4aa978b59067}">
           <p14:sldIdLst>
             <p14:sldId id="274"/>
             <p14:sldId id="275"/>

</xml_diff>